<commit_message>
Reuploaded capstone presentation (PDF + PPTX)
18-slide final report for the IBM Applied Data Science Capstone — Falcon 9 first-stage landing prediction.
</commit_message>
<xml_diff>
--- a/Data Science Capstone Project Report.pptx
+++ b/Data Science Capstone Project Report.pptx
@@ -23,10 +23,9 @@
     <p:sldId id="271" r:id="rId17"/>
     <p:sldId id="272" r:id="rId18"/>
     <p:sldId id="273" r:id="rId19"/>
-    <p:sldId id="274" r:id="rId20"/>
   </p:sldIdLst>
   <p:notesMasterIdLst>
-    <p:notesMasterId r:id="rId21"/>
+    <p:notesMasterId r:id="rId20"/>
   </p:notesMasterIdLst>
   <p:sldSz cx="12191695" cy="6858000"/>
   <p:notesSz cx="6858000" cy="12191695"/>
@@ -1700,94 +1699,6 @@
             <a:fld id="{F7021451-1387-4CA6-816F-3879F97B5CBC}" type="slidenum">
               <a:rPr lang="en-US"/>
               <a:t>18</a:t>
-            </a:fld>
-            <a:endParaRPr lang="en-US"/>
-          </a:p>
-        </p:txBody>
-      </p:sp>
-    </p:spTree>
-    <p:extLst>
-      <p:ext uri="{BB962C8B-B14F-4D97-AF65-F5344CB8AC3E}">
-        <p14:creationId xmlns:p14="http://schemas.microsoft.com/office/powerpoint/2010/main" val="1024086991"/>
-      </p:ext>
-    </p:extLst>
-  </p:cSld>
-  <p:clrMapOvr>
-    <a:masterClrMapping/>
-  </p:clrMapOvr>
-</p:notes>
-</file>
-
-<file path=ppt/notesSlides/notesSlide19.xml><?xml version="1.0" encoding="utf-8"?>
-<p:notes xmlns:a="http://schemas.openxmlformats.org/drawingml/2006/main" xmlns:r="http://schemas.openxmlformats.org/officeDocument/2006/relationships" xmlns:p="http://schemas.openxmlformats.org/presentationml/2006/main">
-  <p:cSld>
-    <p:spTree>
-      <p:nvGrpSpPr>
-        <p:cNvPr id="1" name=""/>
-        <p:cNvGrpSpPr/>
-        <p:nvPr/>
-      </p:nvGrpSpPr>
-      <p:grpSpPr>
-        <a:xfrm>
-          <a:off x="0" y="0"/>
-          <a:ext cx="0" cy="0"/>
-          <a:chOff x="0" y="0"/>
-          <a:chExt cx="0" cy="0"/>
-        </a:xfrm>
-      </p:grpSpPr>
-      <p:sp>
-        <p:nvSpPr>
-          <p:cNvPr id="2" name="Slide Image Placeholder 1"/>
-          <p:cNvSpPr>
-            <a:spLocks noGrp="1" noRot="1" noChangeAspect="1"/>
-          </p:cNvSpPr>
-          <p:nvPr>
-            <p:ph type="sldImg"/>
-          </p:nvPr>
-        </p:nvSpPr>
-        <p:spPr/>
-      </p:sp>
-      <p:sp>
-        <p:nvSpPr>
-          <p:cNvPr id="3" name="Notes Placeholder 2"/>
-          <p:cNvSpPr>
-            <a:spLocks noGrp="1"/>
-          </p:cNvSpPr>
-          <p:nvPr>
-            <p:ph type="body" idx="1"/>
-          </p:nvPr>
-        </p:nvSpPr>
-        <p:spPr/>
-        <p:txBody>
-          <a:bodyPr/>
-          <a:lstStyle/>
-          <a:p>
-            <a:r>
-              <a:rPr lang="en-US" dirty="0"/>
-              <a:t/>
-            </a:r>
-            <a:endParaRPr lang="en-US" dirty="0"/>
-          </a:p>
-        </p:txBody>
-      </p:sp>
-      <p:sp>
-        <p:nvSpPr>
-          <p:cNvPr id="4" name="Slide Number Placeholder 3"/>
-          <p:cNvSpPr>
-            <a:spLocks noGrp="1"/>
-          </p:cNvSpPr>
-          <p:nvPr>
-            <p:ph type="sldNum" sz="quarter" idx="10"/>
-          </p:nvPr>
-        </p:nvSpPr>
-        <p:spPr/>
-        <p:txBody>
-          <a:bodyPr/>
-          <a:lstStyle/>
-          <a:p>
-            <a:fld id="{F7021451-1387-4CA6-816F-3879F97B5CBC}" type="slidenum">
-              <a:rPr lang="en-US"/>
-              <a:t>19</a:t>
             </a:fld>
             <a:endParaRPr lang="en-US"/>
           </a:p>
@@ -6834,29 +6745,7 @@
       </p:grpSpPr>
       <p:sp>
         <p:nvSpPr>
-          <p:cNvPr id="2" name="Shape 0"/>
-          <p:cNvSpPr/>
-          <p:nvPr/>
-        </p:nvSpPr>
-        <p:spPr>
-          <a:xfrm>
-            <a:off x="9692640" y="-1554480"/>
-            <a:ext cx="4572000" cy="4572000"/>
-          </a:xfrm>
-          <a:prstGeom prst="ellipse">
-            <a:avLst/>
-          </a:prstGeom>
-          <a:solidFill>
-            <a:srgbClr val="0B3D91">
-              <a:alpha val="40000"/>
-            </a:srgbClr>
-          </a:solidFill>
-          <a:ln/>
-        </p:spPr>
-      </p:sp>
-      <p:sp>
-        <p:nvSpPr>
-          <p:cNvPr id="3" name="Text 1"/>
+          <p:cNvPr id="2" name="Text 0"/>
           <p:cNvSpPr/>
           <p:nvPr/>
         </p:nvSpPr>
@@ -6884,7 +6773,7 @@
                   <a:srgbClr val="FC3D21"/>
                 </a:solidFill>
               </a:rPr>
-              <a:t>KEY INSIGHT</a:t>
+              <a:t>CONCLUSIONS</a:t>
             </a:r>
             <a:endParaRPr lang="en-US" sz="1300" dirty="0"/>
           </a:p>
@@ -6892,14 +6781,14 @@
       </p:sp>
       <p:sp>
         <p:nvSpPr>
-          <p:cNvPr id="4" name="Text 2"/>
+          <p:cNvPr id="3" name="Text 1"/>
           <p:cNvSpPr/>
           <p:nvPr/>
         </p:nvSpPr>
         <p:spPr>
           <a:xfrm>
             <a:off x="731520" y="822960"/>
-            <a:ext cx="10881360" cy="731520"/>
+            <a:ext cx="10607040" cy="640080"/>
           </a:xfrm>
           <a:prstGeom prst="rect">
             <a:avLst/>
@@ -6923,7 +6812,7 @@
                 <a:ea typeface="Georgia" pitchFamily="34" charset="-122"/>
                 <a:cs typeface="Georgia" pitchFamily="34" charset="-120"/>
               </a:rPr>
-              <a:t>Experience drives recovery, not payload size</a:t>
+              <a:t>What the analysis tells us</a:t>
             </a:r>
             <a:endParaRPr lang="en-US" sz="3000" dirty="0"/>
           </a:p>
@@ -6931,84 +6820,16 @@
       </p:sp>
       <p:sp>
         <p:nvSpPr>
-          <p:cNvPr id="5" name="Text 3"/>
-          <p:cNvSpPr/>
-          <p:nvPr/>
-        </p:nvSpPr>
-        <p:spPr>
-          <a:xfrm>
-            <a:off x="731520" y="1591056"/>
-            <a:ext cx="10881360" cy="640080"/>
-          </a:xfrm>
-          <a:prstGeom prst="rect">
-            <a:avLst/>
-          </a:prstGeom>
-          <a:noFill/>
-          <a:ln/>
-        </p:spPr>
-        <p:txBody>
-          <a:bodyPr wrap="square" lIns="0" tIns="0" rIns="0" bIns="0" rtlCol="0" anchor="t"/>
-          <a:lstStyle/>
-          <a:p>
-            <a:pPr indent="0" marL="0">
-              <a:lnSpc>
-                <a:spcPct val="104000"/>
-              </a:lnSpc>
-              <a:buNone/>
-            </a:pPr>
-            <a:r>
-              <a:rPr lang="en-US" sz="1400" dirty="0">
-                <a:solidFill>
-                  <a:srgbClr val="CADCFC"/>
-                </a:solidFill>
-              </a:rPr>
-              <a:t>Across the visual EDA, the dashboard and the four classifiers, the strongest signal for a successful landing is operational maturity — how far into the program and how proven the booster — rather than how heavy the payload is.</a:t>
-            </a:r>
-            <a:endParaRPr lang="en-US" sz="1400" dirty="0"/>
-          </a:p>
-        </p:txBody>
-      </p:sp>
-      <p:sp>
-        <p:nvSpPr>
-          <p:cNvPr id="6" name="Shape 4"/>
-          <p:cNvSpPr/>
-          <p:nvPr/>
-        </p:nvSpPr>
-        <p:spPr>
-          <a:xfrm>
-            <a:off x="548640" y="2331720"/>
-            <a:ext cx="3502152" cy="2651760"/>
-          </a:xfrm>
-          <a:prstGeom prst="roundRect">
-            <a:avLst>
-              <a:gd name="adj" fmla="val 2759"/>
-            </a:avLst>
-          </a:prstGeom>
-          <a:solidFill>
-            <a:srgbClr val="FFFFFF"/>
-          </a:solidFill>
-          <a:ln/>
-          <a:effectLst>
-            <a:outerShdw sx="100000" sy="100000" kx="0" ky="0" algn="bl" rotWithShape="0" blurRad="88900" dist="38100" dir="8100000">
-              <a:srgbClr val="000000">
-                <a:alpha val="18000"/>
-              </a:srgbClr>
-            </a:outerShdw>
-          </a:effectLst>
-        </p:spPr>
-      </p:sp>
-      <p:sp>
-        <p:nvSpPr>
-          <p:cNvPr id="7" name="Shape 5"/>
-          <p:cNvSpPr/>
-          <p:nvPr/>
-        </p:nvSpPr>
-        <p:spPr>
-          <a:xfrm>
-            <a:off x="548640" y="2331720"/>
-            <a:ext cx="3502152" cy="109728"/>
-          </a:xfrm>
-          <a:prstGeom prst="rect">
+          <p:cNvPr id="4" name="Shape 2"/>
+          <p:cNvSpPr/>
+          <p:nvPr/>
+        </p:nvSpPr>
+        <p:spPr>
+          <a:xfrm>
+            <a:off x="731520" y="1636776"/>
+            <a:ext cx="384048" cy="384048"/>
+          </a:xfrm>
+          <a:prstGeom prst="ellipse">
             <a:avLst/>
           </a:prstGeom>
           <a:solidFill>
@@ -7019,327 +6840,50 @@
       </p:sp>
       <p:sp>
         <p:nvSpPr>
-          <p:cNvPr id="8" name="Text 6"/>
-          <p:cNvSpPr/>
-          <p:nvPr/>
-        </p:nvSpPr>
-        <p:spPr>
-          <a:xfrm>
-            <a:off x="768096" y="2606040"/>
-            <a:ext cx="3063240" cy="2194560"/>
-          </a:xfrm>
-          <a:prstGeom prst="rect">
-            <a:avLst/>
-          </a:prstGeom>
-          <a:noFill/>
-          <a:ln/>
-        </p:spPr>
-        <p:txBody>
-          <a:bodyPr wrap="square" lIns="0" tIns="0" rIns="0" bIns="0" rtlCol="0" anchor="t"/>
-          <a:lstStyle/>
-          <a:p>
-            <a:pPr indent="0" marL="0">
-              <a:spcAft>
-                <a:spcPts val="700"/>
-              </a:spcAft>
+          <p:cNvPr id="5" name="Text 3"/>
+          <p:cNvSpPr/>
+          <p:nvPr/>
+        </p:nvSpPr>
+        <p:spPr>
+          <a:xfrm>
+            <a:off x="731520" y="1636776"/>
+            <a:ext cx="384048" cy="384048"/>
+          </a:xfrm>
+          <a:prstGeom prst="rect">
+            <a:avLst/>
+          </a:prstGeom>
+          <a:noFill/>
+          <a:ln/>
+        </p:spPr>
+        <p:txBody>
+          <a:bodyPr wrap="square" lIns="0" tIns="0" rIns="0" bIns="0" rtlCol="0" anchor="ctr"/>
+          <a:lstStyle/>
+          <a:p>
+            <a:pPr algn="ctr" indent="0" marL="0">
               <a:buNone/>
             </a:pPr>
             <a:r>
               <a:rPr lang="en-US" sz="1500" b="1" dirty="0">
                 <a:solidFill>
-                  <a:srgbClr val="0B1C3D"/>
-                </a:solidFill>
-              </a:rPr>
-              <a:t>A learning curve</a:t>
+                  <a:srgbClr val="FFFFFF"/>
+                </a:solidFill>
+              </a:rPr>
+              <a:t>1</a:t>
             </a:r>
             <a:endParaRPr lang="en-US" sz="1500" dirty="0"/>
           </a:p>
-          <a:p>
-            <a:pPr indent="0" marL="0">
-              <a:lnSpc>
-                <a:spcPct val="105000"/>
-              </a:lnSpc>
-              <a:buNone/>
-            </a:pPr>
-            <a:r>
-              <a:rPr lang="en-US" sz="1150" dirty="0">
-                <a:solidFill>
-                  <a:srgbClr val="1A2233"/>
-                </a:solidFill>
-              </a:rPr>
-              <a:t>Landing success rises steadily with cumulative flight number and year — early failures give way to routine recoveries as the program matures.</a:t>
-            </a:r>
-            <a:endParaRPr lang="en-US" sz="1500" dirty="0"/>
-          </a:p>
-        </p:txBody>
-      </p:sp>
-      <p:sp>
-        <p:nvSpPr>
-          <p:cNvPr id="9" name="Shape 7"/>
-          <p:cNvSpPr/>
-          <p:nvPr/>
-        </p:nvSpPr>
-        <p:spPr>
-          <a:xfrm>
-            <a:off x="4343400" y="2331720"/>
-            <a:ext cx="3502152" cy="2651760"/>
-          </a:xfrm>
-          <a:prstGeom prst="roundRect">
-            <a:avLst>
-              <a:gd name="adj" fmla="val 2759"/>
-            </a:avLst>
-          </a:prstGeom>
-          <a:solidFill>
-            <a:srgbClr val="FFFFFF"/>
-          </a:solidFill>
-          <a:ln/>
-          <a:effectLst>
-            <a:outerShdw sx="100000" sy="100000" kx="0" ky="0" algn="bl" rotWithShape="0" blurRad="88900" dist="38100" dir="8100000">
-              <a:srgbClr val="000000">
-                <a:alpha val="18000"/>
-              </a:srgbClr>
-            </a:outerShdw>
-          </a:effectLst>
-        </p:spPr>
-      </p:sp>
-      <p:sp>
-        <p:nvSpPr>
-          <p:cNvPr id="10" name="Shape 8"/>
-          <p:cNvSpPr/>
-          <p:nvPr/>
-        </p:nvSpPr>
-        <p:spPr>
-          <a:xfrm>
-            <a:off x="4343400" y="2331720"/>
-            <a:ext cx="3502152" cy="109728"/>
-          </a:xfrm>
-          <a:prstGeom prst="rect">
-            <a:avLst/>
-          </a:prstGeom>
-          <a:solidFill>
-            <a:srgbClr val="FC3D21"/>
-          </a:solidFill>
-          <a:ln/>
-        </p:spPr>
-      </p:sp>
-      <p:sp>
-        <p:nvSpPr>
-          <p:cNvPr id="11" name="Text 9"/>
-          <p:cNvSpPr/>
-          <p:nvPr/>
-        </p:nvSpPr>
-        <p:spPr>
-          <a:xfrm>
-            <a:off x="4562856" y="2606040"/>
-            <a:ext cx="3063240" cy="2194560"/>
-          </a:xfrm>
-          <a:prstGeom prst="rect">
-            <a:avLst/>
-          </a:prstGeom>
-          <a:noFill/>
-          <a:ln/>
-        </p:spPr>
-        <p:txBody>
-          <a:bodyPr wrap="square" lIns="0" tIns="0" rIns="0" bIns="0" rtlCol="0" anchor="t"/>
-          <a:lstStyle/>
-          <a:p>
-            <a:pPr indent="0" marL="0">
-              <a:spcAft>
-                <a:spcPts val="700"/>
-              </a:spcAft>
-              <a:buNone/>
-            </a:pPr>
-            <a:r>
-              <a:rPr lang="en-US" sz="1500" b="1" dirty="0">
-                <a:solidFill>
-                  <a:srgbClr val="0B1C3D"/>
-                </a:solidFill>
-              </a:rPr>
-              <a:t>Payload is non-monotonic</a:t>
-            </a:r>
-            <a:endParaRPr lang="en-US" sz="1500" dirty="0"/>
-          </a:p>
-          <a:p>
-            <a:pPr indent="0" marL="0">
-              <a:lnSpc>
-                <a:spcPct val="105000"/>
-              </a:lnSpc>
-              <a:buNone/>
-            </a:pPr>
-            <a:r>
-              <a:rPr lang="en-US" sz="1150" dirty="0">
-                <a:solidFill>
-                  <a:srgbClr val="1A2233"/>
-                </a:solidFill>
-              </a:rPr>
-              <a:t>The 6,000–8,000 kg band lands 0% of the time, while both lighter and some heavier payloads succeed — so payload mass alone is a poor predictor.</a:t>
-            </a:r>
-            <a:endParaRPr lang="en-US" sz="1500" dirty="0"/>
-          </a:p>
-        </p:txBody>
-      </p:sp>
-      <p:sp>
-        <p:nvSpPr>
-          <p:cNvPr id="12" name="Shape 10"/>
-          <p:cNvSpPr/>
-          <p:nvPr/>
-        </p:nvSpPr>
-        <p:spPr>
-          <a:xfrm>
-            <a:off x="8138160" y="2331720"/>
-            <a:ext cx="3502152" cy="2651760"/>
-          </a:xfrm>
-          <a:prstGeom prst="roundRect">
-            <a:avLst>
-              <a:gd name="adj" fmla="val 2759"/>
-            </a:avLst>
-          </a:prstGeom>
-          <a:solidFill>
-            <a:srgbClr val="FFFFFF"/>
-          </a:solidFill>
-          <a:ln/>
-          <a:effectLst>
-            <a:outerShdw sx="100000" sy="100000" kx="0" ky="0" algn="bl" rotWithShape="0" blurRad="88900" dist="38100" dir="8100000">
-              <a:srgbClr val="000000">
-                <a:alpha val="18000"/>
-              </a:srgbClr>
-            </a:outerShdw>
-          </a:effectLst>
-        </p:spPr>
-      </p:sp>
-      <p:sp>
-        <p:nvSpPr>
-          <p:cNvPr id="13" name="Shape 11"/>
-          <p:cNvSpPr/>
-          <p:nvPr/>
-        </p:nvSpPr>
-        <p:spPr>
-          <a:xfrm>
-            <a:off x="8138160" y="2331720"/>
-            <a:ext cx="3502152" cy="109728"/>
-          </a:xfrm>
-          <a:prstGeom prst="rect">
-            <a:avLst/>
-          </a:prstGeom>
-          <a:solidFill>
-            <a:srgbClr val="FC3D21"/>
-          </a:solidFill>
-          <a:ln/>
-        </p:spPr>
-      </p:sp>
-      <p:sp>
-        <p:nvSpPr>
-          <p:cNvPr id="14" name="Text 12"/>
-          <p:cNvSpPr/>
-          <p:nvPr/>
-        </p:nvSpPr>
-        <p:spPr>
-          <a:xfrm>
-            <a:off x="8357616" y="2606040"/>
-            <a:ext cx="3063240" cy="2194560"/>
-          </a:xfrm>
-          <a:prstGeom prst="rect">
-            <a:avLst/>
-          </a:prstGeom>
-          <a:noFill/>
-          <a:ln/>
-        </p:spPr>
-        <p:txBody>
-          <a:bodyPr wrap="square" lIns="0" tIns="0" rIns="0" bIns="0" rtlCol="0" anchor="t"/>
-          <a:lstStyle/>
-          <a:p>
-            <a:pPr indent="0" marL="0">
-              <a:spcAft>
-                <a:spcPts val="700"/>
-              </a:spcAft>
-              <a:buNone/>
-            </a:pPr>
-            <a:r>
-              <a:rPr lang="en-US" sz="1500" b="1" dirty="0">
-                <a:solidFill>
-                  <a:srgbClr val="0B1C3D"/>
-                </a:solidFill>
-              </a:rPr>
-              <a:t>The models concur</a:t>
-            </a:r>
-            <a:endParaRPr lang="en-US" sz="1500" dirty="0"/>
-          </a:p>
-          <a:p>
-            <a:pPr indent="0" marL="0">
-              <a:lnSpc>
-                <a:spcPct val="105000"/>
-              </a:lnSpc>
-              <a:buNone/>
-            </a:pPr>
-            <a:r>
-              <a:rPr lang="en-US" sz="1150" dirty="0">
-                <a:solidFill>
-                  <a:srgbClr val="1A2233"/>
-                </a:solidFill>
-              </a:rPr>
-              <a:t>A linear SVM/LR tops the table (0.833); the axis-aligned decision tree trails (0.722). The signal is largely linearly separable — experience, site, booster — not a payload cutoff.</a:t>
-            </a:r>
-            <a:endParaRPr lang="en-US" sz="1500" dirty="0"/>
-          </a:p>
-        </p:txBody>
-      </p:sp>
-      <p:sp>
-        <p:nvSpPr>
-          <p:cNvPr id="15" name="Shape 13"/>
-          <p:cNvSpPr/>
-          <p:nvPr/>
-        </p:nvSpPr>
-        <p:spPr>
-          <a:xfrm>
-            <a:off x="548640" y="5166360"/>
-            <a:ext cx="11091672" cy="914400"/>
-          </a:xfrm>
-          <a:prstGeom prst="rect">
-            <a:avLst/>
-          </a:prstGeom>
-          <a:solidFill>
-            <a:srgbClr val="0B3D91"/>
-          </a:solidFill>
-          <a:ln/>
-          <a:effectLst>
-            <a:outerShdw sx="100000" sy="100000" kx="0" ky="0" algn="bl" rotWithShape="0" blurRad="88900" dist="38100" dir="8100000">
-              <a:srgbClr val="000000">
-                <a:alpha val="18000"/>
-              </a:srgbClr>
-            </a:outerShdw>
-          </a:effectLst>
-        </p:spPr>
-      </p:sp>
-      <p:sp>
-        <p:nvSpPr>
-          <p:cNvPr id="16" name="Shape 14"/>
-          <p:cNvSpPr/>
-          <p:nvPr/>
-        </p:nvSpPr>
-        <p:spPr>
-          <a:xfrm>
-            <a:off x="548640" y="5166360"/>
-            <a:ext cx="128016" cy="914400"/>
-          </a:xfrm>
-          <a:prstGeom prst="rect">
-            <a:avLst/>
-          </a:prstGeom>
-          <a:solidFill>
-            <a:srgbClr val="FC3D21"/>
-          </a:solidFill>
-          <a:ln/>
-        </p:spPr>
-      </p:sp>
-      <p:sp>
-        <p:nvSpPr>
-          <p:cNvPr id="17" name="Text 15"/>
-          <p:cNvSpPr/>
-          <p:nvPr/>
-        </p:nvSpPr>
-        <p:spPr>
-          <a:xfrm>
-            <a:off x="868680" y="5166360"/>
-            <a:ext cx="10607040" cy="914400"/>
+        </p:txBody>
+      </p:sp>
+      <p:sp>
+        <p:nvSpPr>
+          <p:cNvPr id="6" name="Text 4"/>
+          <p:cNvSpPr/>
+          <p:nvPr/>
+        </p:nvSpPr>
+        <p:spPr>
+          <a:xfrm>
+            <a:off x="1325880" y="1554480"/>
+            <a:ext cx="10241280" cy="914400"/>
           </a:xfrm>
           <a:prstGeom prst="rect">
             <a:avLst/>
@@ -7358,12 +6902,12 @@
               <a:buNone/>
             </a:pPr>
             <a:r>
-              <a:rPr lang="en-US" sz="1300" b="1" dirty="0">
+              <a:rPr lang="en-US" sz="1400" b="1" dirty="0">
                 <a:solidFill>
                   <a:srgbClr val="FFFFFF"/>
                 </a:solidFill>
               </a:rPr>
-              <a:t>Implication for a competitor   </a:t>
+              <a:t>Recovery is a learning curve  </a:t>
             </a:r>
             <a:pPr indent="0" marL="0">
               <a:lnSpc>
@@ -7377,15 +6921,451 @@
                   <a:srgbClr val="CADCFC"/>
                 </a:solidFill>
               </a:rPr>
-              <a:t>weight booster generation, launch site and flight heritage above payload mass when estimating first-stage recovery — and the ~$100M cost gap each landing represents.</a:t>
-            </a:r>
-            <a:endParaRPr lang="en-US" sz="1300" dirty="0"/>
+              <a:t>Landing success rose steadily year over year and with cumulative flight number — early failures gave way to routine recoveries.</a:t>
+            </a:r>
+            <a:endParaRPr lang="en-US" sz="1400" dirty="0"/>
+          </a:p>
+        </p:txBody>
+      </p:sp>
+      <p:sp>
+        <p:nvSpPr>
+          <p:cNvPr id="7" name="Shape 5"/>
+          <p:cNvSpPr/>
+          <p:nvPr/>
+        </p:nvSpPr>
+        <p:spPr>
+          <a:xfrm>
+            <a:off x="731520" y="2587752"/>
+            <a:ext cx="384048" cy="384048"/>
+          </a:xfrm>
+          <a:prstGeom prst="ellipse">
+            <a:avLst/>
+          </a:prstGeom>
+          <a:solidFill>
+            <a:srgbClr val="FC3D21"/>
+          </a:solidFill>
+          <a:ln/>
+        </p:spPr>
+      </p:sp>
+      <p:sp>
+        <p:nvSpPr>
+          <p:cNvPr id="8" name="Text 6"/>
+          <p:cNvSpPr/>
+          <p:nvPr/>
+        </p:nvSpPr>
+        <p:spPr>
+          <a:xfrm>
+            <a:off x="731520" y="2587752"/>
+            <a:ext cx="384048" cy="384048"/>
+          </a:xfrm>
+          <a:prstGeom prst="rect">
+            <a:avLst/>
+          </a:prstGeom>
+          <a:noFill/>
+          <a:ln/>
+        </p:spPr>
+        <p:txBody>
+          <a:bodyPr wrap="square" lIns="0" tIns="0" rIns="0" bIns="0" rtlCol="0" anchor="ctr"/>
+          <a:lstStyle/>
+          <a:p>
+            <a:pPr algn="ctr" indent="0" marL="0">
+              <a:buNone/>
+            </a:pPr>
+            <a:r>
+              <a:rPr lang="en-US" sz="1500" b="1" dirty="0">
+                <a:solidFill>
+                  <a:srgbClr val="FFFFFF"/>
+                </a:solidFill>
+              </a:rPr>
+              <a:t>2</a:t>
+            </a:r>
+            <a:endParaRPr lang="en-US" sz="1500" dirty="0"/>
+          </a:p>
+        </p:txBody>
+      </p:sp>
+      <p:sp>
+        <p:nvSpPr>
+          <p:cNvPr id="9" name="Text 7"/>
+          <p:cNvSpPr/>
+          <p:nvPr/>
+        </p:nvSpPr>
+        <p:spPr>
+          <a:xfrm>
+            <a:off x="1325880" y="2505456"/>
+            <a:ext cx="10241280" cy="914400"/>
+          </a:xfrm>
+          <a:prstGeom prst="rect">
+            <a:avLst/>
+          </a:prstGeom>
+          <a:noFill/>
+          <a:ln/>
+        </p:spPr>
+        <p:txBody>
+          <a:bodyPr wrap="square" lIns="0" tIns="0" rIns="0" bIns="0" rtlCol="0" anchor="ctr"/>
+          <a:lstStyle/>
+          <a:p>
+            <a:pPr indent="0" marL="0">
+              <a:lnSpc>
+                <a:spcPct val="103000"/>
+              </a:lnSpc>
+              <a:buNone/>
+            </a:pPr>
+            <a:r>
+              <a:rPr lang="en-US" sz="1400" b="1" dirty="0">
+                <a:solidFill>
+                  <a:srgbClr val="FFFFFF"/>
+                </a:solidFill>
+              </a:rPr>
+              <a:t>Mission profile decides the odds  </a:t>
+            </a:r>
+            <a:pPr indent="0" marL="0">
+              <a:lnSpc>
+                <a:spcPct val="103000"/>
+              </a:lnSpc>
+              <a:buNone/>
+            </a:pPr>
+            <a:r>
+              <a:rPr lang="en-US" sz="1250" dirty="0">
+                <a:solidFill>
+                  <a:srgbClr val="CADCFC"/>
+                </a:solidFill>
+              </a:rPr>
+              <a:t>Success depends strongly on orbit type and payload mass; lighter payloads and orbits such as ES-L1, GEO, HEO and SSO land most reliably.</a:t>
+            </a:r>
+            <a:endParaRPr lang="en-US" sz="1400" dirty="0"/>
+          </a:p>
+        </p:txBody>
+      </p:sp>
+      <p:sp>
+        <p:nvSpPr>
+          <p:cNvPr id="10" name="Shape 8"/>
+          <p:cNvSpPr/>
+          <p:nvPr/>
+        </p:nvSpPr>
+        <p:spPr>
+          <a:xfrm>
+            <a:off x="731520" y="3538728"/>
+            <a:ext cx="384048" cy="384048"/>
+          </a:xfrm>
+          <a:prstGeom prst="ellipse">
+            <a:avLst/>
+          </a:prstGeom>
+          <a:solidFill>
+            <a:srgbClr val="FC3D21"/>
+          </a:solidFill>
+          <a:ln/>
+        </p:spPr>
+      </p:sp>
+      <p:sp>
+        <p:nvSpPr>
+          <p:cNvPr id="11" name="Text 9"/>
+          <p:cNvSpPr/>
+          <p:nvPr/>
+        </p:nvSpPr>
+        <p:spPr>
+          <a:xfrm>
+            <a:off x="731520" y="3538728"/>
+            <a:ext cx="384048" cy="384048"/>
+          </a:xfrm>
+          <a:prstGeom prst="rect">
+            <a:avLst/>
+          </a:prstGeom>
+          <a:noFill/>
+          <a:ln/>
+        </p:spPr>
+        <p:txBody>
+          <a:bodyPr wrap="square" lIns="0" tIns="0" rIns="0" bIns="0" rtlCol="0" anchor="ctr"/>
+          <a:lstStyle/>
+          <a:p>
+            <a:pPr algn="ctr" indent="0" marL="0">
+              <a:buNone/>
+            </a:pPr>
+            <a:r>
+              <a:rPr lang="en-US" sz="1500" b="1" dirty="0">
+                <a:solidFill>
+                  <a:srgbClr val="FFFFFF"/>
+                </a:solidFill>
+              </a:rPr>
+              <a:t>3</a:t>
+            </a:r>
+            <a:endParaRPr lang="en-US" sz="1500" dirty="0"/>
+          </a:p>
+        </p:txBody>
+      </p:sp>
+      <p:sp>
+        <p:nvSpPr>
+          <p:cNvPr id="12" name="Text 10"/>
+          <p:cNvSpPr/>
+          <p:nvPr/>
+        </p:nvSpPr>
+        <p:spPr>
+          <a:xfrm>
+            <a:off x="1325880" y="3456432"/>
+            <a:ext cx="10241280" cy="914400"/>
+          </a:xfrm>
+          <a:prstGeom prst="rect">
+            <a:avLst/>
+          </a:prstGeom>
+          <a:noFill/>
+          <a:ln/>
+        </p:spPr>
+        <p:txBody>
+          <a:bodyPr wrap="square" lIns="0" tIns="0" rIns="0" bIns="0" rtlCol="0" anchor="ctr"/>
+          <a:lstStyle/>
+          <a:p>
+            <a:pPr indent="0" marL="0">
+              <a:lnSpc>
+                <a:spcPct val="103000"/>
+              </a:lnSpc>
+              <a:buNone/>
+            </a:pPr>
+            <a:r>
+              <a:rPr lang="en-US" sz="1400" b="1" dirty="0">
+                <a:solidFill>
+                  <a:srgbClr val="FFFFFF"/>
+                </a:solidFill>
+              </a:rPr>
+              <a:t>Site &amp; booster matter  </a:t>
+            </a:r>
+            <a:pPr indent="0" marL="0">
+              <a:lnSpc>
+                <a:spcPct val="103000"/>
+              </a:lnSpc>
+              <a:buNone/>
+            </a:pPr>
+            <a:r>
+              <a:rPr lang="en-US" sz="1250" dirty="0">
+                <a:solidFill>
+                  <a:srgbClr val="CADCFC"/>
+                </a:solidFill>
+              </a:rPr>
+              <a:t>KSC LC-39A is the most successful site and the FT-generation boosters recover most often.</a:t>
+            </a:r>
+            <a:endParaRPr lang="en-US" sz="1400" dirty="0"/>
+          </a:p>
+        </p:txBody>
+      </p:sp>
+      <p:sp>
+        <p:nvSpPr>
+          <p:cNvPr id="13" name="Shape 11"/>
+          <p:cNvSpPr/>
+          <p:nvPr/>
+        </p:nvSpPr>
+        <p:spPr>
+          <a:xfrm>
+            <a:off x="731520" y="4489704"/>
+            <a:ext cx="384048" cy="384048"/>
+          </a:xfrm>
+          <a:prstGeom prst="ellipse">
+            <a:avLst/>
+          </a:prstGeom>
+          <a:solidFill>
+            <a:srgbClr val="FC3D21"/>
+          </a:solidFill>
+          <a:ln/>
+        </p:spPr>
+      </p:sp>
+      <p:sp>
+        <p:nvSpPr>
+          <p:cNvPr id="14" name="Text 12"/>
+          <p:cNvSpPr/>
+          <p:nvPr/>
+        </p:nvSpPr>
+        <p:spPr>
+          <a:xfrm>
+            <a:off x="731520" y="4489704"/>
+            <a:ext cx="384048" cy="384048"/>
+          </a:xfrm>
+          <a:prstGeom prst="rect">
+            <a:avLst/>
+          </a:prstGeom>
+          <a:noFill/>
+          <a:ln/>
+        </p:spPr>
+        <p:txBody>
+          <a:bodyPr wrap="square" lIns="0" tIns="0" rIns="0" bIns="0" rtlCol="0" anchor="ctr"/>
+          <a:lstStyle/>
+          <a:p>
+            <a:pPr algn="ctr" indent="0" marL="0">
+              <a:buNone/>
+            </a:pPr>
+            <a:r>
+              <a:rPr lang="en-US" sz="1500" b="1" dirty="0">
+                <a:solidFill>
+                  <a:srgbClr val="FFFFFF"/>
+                </a:solidFill>
+              </a:rPr>
+              <a:t>4</a:t>
+            </a:r>
+            <a:endParaRPr lang="en-US" sz="1500" dirty="0"/>
+          </a:p>
+        </p:txBody>
+      </p:sp>
+      <p:sp>
+        <p:nvSpPr>
+          <p:cNvPr id="15" name="Text 13"/>
+          <p:cNvSpPr/>
+          <p:nvPr/>
+        </p:nvSpPr>
+        <p:spPr>
+          <a:xfrm>
+            <a:off x="1325880" y="4407408"/>
+            <a:ext cx="10241280" cy="914400"/>
+          </a:xfrm>
+          <a:prstGeom prst="rect">
+            <a:avLst/>
+          </a:prstGeom>
+          <a:noFill/>
+          <a:ln/>
+        </p:spPr>
+        <p:txBody>
+          <a:bodyPr wrap="square" lIns="0" tIns="0" rIns="0" bIns="0" rtlCol="0" anchor="ctr"/>
+          <a:lstStyle/>
+          <a:p>
+            <a:pPr indent="0" marL="0">
+              <a:lnSpc>
+                <a:spcPct val="103000"/>
+              </a:lnSpc>
+              <a:buNone/>
+            </a:pPr>
+            <a:r>
+              <a:rPr lang="en-US" sz="1400" b="1" dirty="0">
+                <a:solidFill>
+                  <a:srgbClr val="FFFFFF"/>
+                </a:solidFill>
+              </a:rPr>
+              <a:t>Prediction works — with a caveat  </a:t>
+            </a:r>
+            <a:pPr indent="0" marL="0">
+              <a:lnSpc>
+                <a:spcPct val="103000"/>
+              </a:lnSpc>
+              <a:buNone/>
+            </a:pPr>
+            <a:r>
+              <a:rPr lang="en-US" sz="1250" dirty="0">
+                <a:solidFill>
+                  <a:srgbClr val="CADCFC"/>
+                </a:solidFill>
+              </a:rPr>
+              <a:t>Four classifiers reach ~83% test accuracy (SVM best on CV). With only 18 test samples the models are effectively tied; more data is needed to separate them.</a:t>
+            </a:r>
+            <a:endParaRPr lang="en-US" sz="1400" dirty="0"/>
+          </a:p>
+        </p:txBody>
+      </p:sp>
+      <p:sp>
+        <p:nvSpPr>
+          <p:cNvPr id="16" name="Shape 14"/>
+          <p:cNvSpPr/>
+          <p:nvPr/>
+        </p:nvSpPr>
+        <p:spPr>
+          <a:xfrm>
+            <a:off x="731520" y="5440680"/>
+            <a:ext cx="384048" cy="384048"/>
+          </a:xfrm>
+          <a:prstGeom prst="ellipse">
+            <a:avLst/>
+          </a:prstGeom>
+          <a:solidFill>
+            <a:srgbClr val="FC3D21"/>
+          </a:solidFill>
+          <a:ln/>
+        </p:spPr>
+      </p:sp>
+      <p:sp>
+        <p:nvSpPr>
+          <p:cNvPr id="17" name="Text 15"/>
+          <p:cNvSpPr/>
+          <p:nvPr/>
+        </p:nvSpPr>
+        <p:spPr>
+          <a:xfrm>
+            <a:off x="731520" y="5440680"/>
+            <a:ext cx="384048" cy="384048"/>
+          </a:xfrm>
+          <a:prstGeom prst="rect">
+            <a:avLst/>
+          </a:prstGeom>
+          <a:noFill/>
+          <a:ln/>
+        </p:spPr>
+        <p:txBody>
+          <a:bodyPr wrap="square" lIns="0" tIns="0" rIns="0" bIns="0" rtlCol="0" anchor="ctr"/>
+          <a:lstStyle/>
+          <a:p>
+            <a:pPr algn="ctr" indent="0" marL="0">
+              <a:buNone/>
+            </a:pPr>
+            <a:r>
+              <a:rPr lang="en-US" sz="1500" b="1" dirty="0">
+                <a:solidFill>
+                  <a:srgbClr val="FFFFFF"/>
+                </a:solidFill>
+              </a:rPr>
+              <a:t>5</a:t>
+            </a:r>
+            <a:endParaRPr lang="en-US" sz="1500" dirty="0"/>
           </a:p>
         </p:txBody>
       </p:sp>
       <p:sp>
         <p:nvSpPr>
           <p:cNvPr id="18" name="Text 16"/>
+          <p:cNvSpPr/>
+          <p:nvPr/>
+        </p:nvSpPr>
+        <p:spPr>
+          <a:xfrm>
+            <a:off x="1325880" y="5358384"/>
+            <a:ext cx="10241280" cy="914400"/>
+          </a:xfrm>
+          <a:prstGeom prst="rect">
+            <a:avLst/>
+          </a:prstGeom>
+          <a:noFill/>
+          <a:ln/>
+        </p:spPr>
+        <p:txBody>
+          <a:bodyPr wrap="square" lIns="0" tIns="0" rIns="0" bIns="0" rtlCol="0" anchor="ctr"/>
+          <a:lstStyle/>
+          <a:p>
+            <a:pPr indent="0" marL="0">
+              <a:lnSpc>
+                <a:spcPct val="103000"/>
+              </a:lnSpc>
+              <a:buNone/>
+            </a:pPr>
+            <a:r>
+              <a:rPr lang="en-US" sz="1400" b="1" dirty="0">
+                <a:solidFill>
+                  <a:srgbClr val="FFFFFF"/>
+                </a:solidFill>
+              </a:rPr>
+              <a:t>Business takeaway  </a:t>
+            </a:r>
+            <a:pPr indent="0" marL="0">
+              <a:lnSpc>
+                <a:spcPct val="103000"/>
+              </a:lnSpc>
+              <a:buNone/>
+            </a:pPr>
+            <a:r>
+              <a:rPr lang="en-US" sz="1250" dirty="0">
+                <a:solidFill>
+                  <a:srgbClr val="CADCFC"/>
+                </a:solidFill>
+              </a:rPr>
+              <a:t>Landing — and therefore the ~$100M cost gap per launch — can be predicted from public attributes, directly informing a competitor's bid.</a:t>
+            </a:r>
+            <a:endParaRPr lang="en-US" sz="1400" dirty="0"/>
+          </a:p>
+        </p:txBody>
+      </p:sp>
+      <p:sp>
+        <p:nvSpPr>
+          <p:cNvPr id="19" name="Text 17"/>
           <p:cNvSpPr/>
           <p:nvPr/>
         </p:nvSpPr>
@@ -7421,7 +7401,7 @@
       </p:sp>
       <p:sp>
         <p:nvSpPr>
-          <p:cNvPr id="19" name="Text 17"/>
+          <p:cNvPr id="20" name="Text 18"/>
           <p:cNvSpPr/>
           <p:nvPr/>
         </p:nvSpPr>
@@ -7466,730 +7446,6 @@
 <file path=ppt/slides/slide18.xml><?xml version="1.0" encoding="utf-8"?>
 <p:sld xmlns:a="http://schemas.openxmlformats.org/drawingml/2006/main" xmlns:r="http://schemas.openxmlformats.org/officeDocument/2006/relationships" xmlns:p="http://schemas.openxmlformats.org/presentationml/2006/main">
   <p:cSld name="Slide 18">
-    <p:bg>
-      <p:bgPr>
-        <a:solidFill>
-          <a:srgbClr val="0B1C3D"/>
-        </a:solidFill>
-      </p:bgPr>
-    </p:bg>
-    <p:spTree>
-      <p:nvGrpSpPr>
-        <p:cNvPr id="1" name=""/>
-        <p:cNvGrpSpPr/>
-        <p:nvPr/>
-      </p:nvGrpSpPr>
-      <p:grpSpPr>
-        <a:xfrm>
-          <a:off x="0" y="0"/>
-          <a:ext cx="0" cy="0"/>
-          <a:chOff x="0" y="0"/>
-          <a:chExt cx="0" cy="0"/>
-        </a:xfrm>
-      </p:grpSpPr>
-      <p:sp>
-        <p:nvSpPr>
-          <p:cNvPr id="2" name="Text 0"/>
-          <p:cNvSpPr/>
-          <p:nvPr/>
-        </p:nvSpPr>
-        <p:spPr>
-          <a:xfrm>
-            <a:off x="731520" y="502920"/>
-            <a:ext cx="10058400" cy="320040"/>
-          </a:xfrm>
-          <a:prstGeom prst="rect">
-            <a:avLst/>
-          </a:prstGeom>
-          <a:noFill/>
-          <a:ln/>
-        </p:spPr>
-        <p:txBody>
-          <a:bodyPr wrap="square" lIns="0" tIns="0" rIns="0" bIns="0" rtlCol="0" anchor="ctr"/>
-          <a:lstStyle/>
-          <a:p>
-            <a:pPr indent="0" marL="0">
-              <a:buNone/>
-            </a:pPr>
-            <a:r>
-              <a:rPr lang="en-US" sz="1300" b="1" spc="300" kern="0" dirty="0">
-                <a:solidFill>
-                  <a:srgbClr val="FC3D21"/>
-                </a:solidFill>
-              </a:rPr>
-              <a:t>CONCLUSIONS</a:t>
-            </a:r>
-            <a:endParaRPr lang="en-US" sz="1300" dirty="0"/>
-          </a:p>
-        </p:txBody>
-      </p:sp>
-      <p:sp>
-        <p:nvSpPr>
-          <p:cNvPr id="3" name="Text 1"/>
-          <p:cNvSpPr/>
-          <p:nvPr/>
-        </p:nvSpPr>
-        <p:spPr>
-          <a:xfrm>
-            <a:off x="731520" y="822960"/>
-            <a:ext cx="10607040" cy="640080"/>
-          </a:xfrm>
-          <a:prstGeom prst="rect">
-            <a:avLst/>
-          </a:prstGeom>
-          <a:noFill/>
-          <a:ln/>
-        </p:spPr>
-        <p:txBody>
-          <a:bodyPr wrap="square" lIns="0" tIns="0" rIns="0" bIns="0" rtlCol="0" anchor="ctr"/>
-          <a:lstStyle/>
-          <a:p>
-            <a:pPr indent="0" marL="0">
-              <a:buNone/>
-            </a:pPr>
-            <a:r>
-              <a:rPr lang="en-US" sz="3000" b="1" dirty="0">
-                <a:solidFill>
-                  <a:srgbClr val="FFFFFF"/>
-                </a:solidFill>
-                <a:latin typeface="Georgia" pitchFamily="34" charset="0"/>
-                <a:ea typeface="Georgia" pitchFamily="34" charset="-122"/>
-                <a:cs typeface="Georgia" pitchFamily="34" charset="-120"/>
-              </a:rPr>
-              <a:t>What the analysis tells us</a:t>
-            </a:r>
-            <a:endParaRPr lang="en-US" sz="3000" dirty="0"/>
-          </a:p>
-        </p:txBody>
-      </p:sp>
-      <p:sp>
-        <p:nvSpPr>
-          <p:cNvPr id="4" name="Shape 2"/>
-          <p:cNvSpPr/>
-          <p:nvPr/>
-        </p:nvSpPr>
-        <p:spPr>
-          <a:xfrm>
-            <a:off x="731520" y="1636776"/>
-            <a:ext cx="384048" cy="384048"/>
-          </a:xfrm>
-          <a:prstGeom prst="ellipse">
-            <a:avLst/>
-          </a:prstGeom>
-          <a:solidFill>
-            <a:srgbClr val="FC3D21"/>
-          </a:solidFill>
-          <a:ln/>
-        </p:spPr>
-      </p:sp>
-      <p:sp>
-        <p:nvSpPr>
-          <p:cNvPr id="5" name="Text 3"/>
-          <p:cNvSpPr/>
-          <p:nvPr/>
-        </p:nvSpPr>
-        <p:spPr>
-          <a:xfrm>
-            <a:off x="731520" y="1636776"/>
-            <a:ext cx="384048" cy="384048"/>
-          </a:xfrm>
-          <a:prstGeom prst="rect">
-            <a:avLst/>
-          </a:prstGeom>
-          <a:noFill/>
-          <a:ln/>
-        </p:spPr>
-        <p:txBody>
-          <a:bodyPr wrap="square" lIns="0" tIns="0" rIns="0" bIns="0" rtlCol="0" anchor="ctr"/>
-          <a:lstStyle/>
-          <a:p>
-            <a:pPr algn="ctr" indent="0" marL="0">
-              <a:buNone/>
-            </a:pPr>
-            <a:r>
-              <a:rPr lang="en-US" sz="1500" b="1" dirty="0">
-                <a:solidFill>
-                  <a:srgbClr val="FFFFFF"/>
-                </a:solidFill>
-              </a:rPr>
-              <a:t>1</a:t>
-            </a:r>
-            <a:endParaRPr lang="en-US" sz="1500" dirty="0"/>
-          </a:p>
-        </p:txBody>
-      </p:sp>
-      <p:sp>
-        <p:nvSpPr>
-          <p:cNvPr id="6" name="Text 4"/>
-          <p:cNvSpPr/>
-          <p:nvPr/>
-        </p:nvSpPr>
-        <p:spPr>
-          <a:xfrm>
-            <a:off x="1325880" y="1554480"/>
-            <a:ext cx="10241280" cy="914400"/>
-          </a:xfrm>
-          <a:prstGeom prst="rect">
-            <a:avLst/>
-          </a:prstGeom>
-          <a:noFill/>
-          <a:ln/>
-        </p:spPr>
-        <p:txBody>
-          <a:bodyPr wrap="square" lIns="0" tIns="0" rIns="0" bIns="0" rtlCol="0" anchor="ctr"/>
-          <a:lstStyle/>
-          <a:p>
-            <a:pPr indent="0" marL="0">
-              <a:lnSpc>
-                <a:spcPct val="103000"/>
-              </a:lnSpc>
-              <a:buNone/>
-            </a:pPr>
-            <a:r>
-              <a:rPr lang="en-US" sz="1400" b="1" dirty="0">
-                <a:solidFill>
-                  <a:srgbClr val="FFFFFF"/>
-                </a:solidFill>
-              </a:rPr>
-              <a:t>Recovery is a learning curve  </a:t>
-            </a:r>
-            <a:pPr indent="0" marL="0">
-              <a:lnSpc>
-                <a:spcPct val="103000"/>
-              </a:lnSpc>
-              <a:buNone/>
-            </a:pPr>
-            <a:r>
-              <a:rPr lang="en-US" sz="1250" dirty="0">
-                <a:solidFill>
-                  <a:srgbClr val="CADCFC"/>
-                </a:solidFill>
-              </a:rPr>
-              <a:t>Landing success rose steadily year over year and with cumulative flight number — early failures gave way to routine recoveries.</a:t>
-            </a:r>
-            <a:endParaRPr lang="en-US" sz="1400" dirty="0"/>
-          </a:p>
-        </p:txBody>
-      </p:sp>
-      <p:sp>
-        <p:nvSpPr>
-          <p:cNvPr id="7" name="Shape 5"/>
-          <p:cNvSpPr/>
-          <p:nvPr/>
-        </p:nvSpPr>
-        <p:spPr>
-          <a:xfrm>
-            <a:off x="731520" y="2587752"/>
-            <a:ext cx="384048" cy="384048"/>
-          </a:xfrm>
-          <a:prstGeom prst="ellipse">
-            <a:avLst/>
-          </a:prstGeom>
-          <a:solidFill>
-            <a:srgbClr val="FC3D21"/>
-          </a:solidFill>
-          <a:ln/>
-        </p:spPr>
-      </p:sp>
-      <p:sp>
-        <p:nvSpPr>
-          <p:cNvPr id="8" name="Text 6"/>
-          <p:cNvSpPr/>
-          <p:nvPr/>
-        </p:nvSpPr>
-        <p:spPr>
-          <a:xfrm>
-            <a:off x="731520" y="2587752"/>
-            <a:ext cx="384048" cy="384048"/>
-          </a:xfrm>
-          <a:prstGeom prst="rect">
-            <a:avLst/>
-          </a:prstGeom>
-          <a:noFill/>
-          <a:ln/>
-        </p:spPr>
-        <p:txBody>
-          <a:bodyPr wrap="square" lIns="0" tIns="0" rIns="0" bIns="0" rtlCol="0" anchor="ctr"/>
-          <a:lstStyle/>
-          <a:p>
-            <a:pPr algn="ctr" indent="0" marL="0">
-              <a:buNone/>
-            </a:pPr>
-            <a:r>
-              <a:rPr lang="en-US" sz="1500" b="1" dirty="0">
-                <a:solidFill>
-                  <a:srgbClr val="FFFFFF"/>
-                </a:solidFill>
-              </a:rPr>
-              <a:t>2</a:t>
-            </a:r>
-            <a:endParaRPr lang="en-US" sz="1500" dirty="0"/>
-          </a:p>
-        </p:txBody>
-      </p:sp>
-      <p:sp>
-        <p:nvSpPr>
-          <p:cNvPr id="9" name="Text 7"/>
-          <p:cNvSpPr/>
-          <p:nvPr/>
-        </p:nvSpPr>
-        <p:spPr>
-          <a:xfrm>
-            <a:off x="1325880" y="2505456"/>
-            <a:ext cx="10241280" cy="914400"/>
-          </a:xfrm>
-          <a:prstGeom prst="rect">
-            <a:avLst/>
-          </a:prstGeom>
-          <a:noFill/>
-          <a:ln/>
-        </p:spPr>
-        <p:txBody>
-          <a:bodyPr wrap="square" lIns="0" tIns="0" rIns="0" bIns="0" rtlCol="0" anchor="ctr"/>
-          <a:lstStyle/>
-          <a:p>
-            <a:pPr indent="0" marL="0">
-              <a:lnSpc>
-                <a:spcPct val="103000"/>
-              </a:lnSpc>
-              <a:buNone/>
-            </a:pPr>
-            <a:r>
-              <a:rPr lang="en-US" sz="1400" b="1" dirty="0">
-                <a:solidFill>
-                  <a:srgbClr val="FFFFFF"/>
-                </a:solidFill>
-              </a:rPr>
-              <a:t>Mission profile decides the odds  </a:t>
-            </a:r>
-            <a:pPr indent="0" marL="0">
-              <a:lnSpc>
-                <a:spcPct val="103000"/>
-              </a:lnSpc>
-              <a:buNone/>
-            </a:pPr>
-            <a:r>
-              <a:rPr lang="en-US" sz="1250" dirty="0">
-                <a:solidFill>
-                  <a:srgbClr val="CADCFC"/>
-                </a:solidFill>
-              </a:rPr>
-              <a:t>Success depends strongly on orbit type and payload mass; lighter payloads and orbits such as ES-L1, GEO, HEO and SSO land most reliably.</a:t>
-            </a:r>
-            <a:endParaRPr lang="en-US" sz="1400" dirty="0"/>
-          </a:p>
-        </p:txBody>
-      </p:sp>
-      <p:sp>
-        <p:nvSpPr>
-          <p:cNvPr id="10" name="Shape 8"/>
-          <p:cNvSpPr/>
-          <p:nvPr/>
-        </p:nvSpPr>
-        <p:spPr>
-          <a:xfrm>
-            <a:off x="731520" y="3538728"/>
-            <a:ext cx="384048" cy="384048"/>
-          </a:xfrm>
-          <a:prstGeom prst="ellipse">
-            <a:avLst/>
-          </a:prstGeom>
-          <a:solidFill>
-            <a:srgbClr val="FC3D21"/>
-          </a:solidFill>
-          <a:ln/>
-        </p:spPr>
-      </p:sp>
-      <p:sp>
-        <p:nvSpPr>
-          <p:cNvPr id="11" name="Text 9"/>
-          <p:cNvSpPr/>
-          <p:nvPr/>
-        </p:nvSpPr>
-        <p:spPr>
-          <a:xfrm>
-            <a:off x="731520" y="3538728"/>
-            <a:ext cx="384048" cy="384048"/>
-          </a:xfrm>
-          <a:prstGeom prst="rect">
-            <a:avLst/>
-          </a:prstGeom>
-          <a:noFill/>
-          <a:ln/>
-        </p:spPr>
-        <p:txBody>
-          <a:bodyPr wrap="square" lIns="0" tIns="0" rIns="0" bIns="0" rtlCol="0" anchor="ctr"/>
-          <a:lstStyle/>
-          <a:p>
-            <a:pPr algn="ctr" indent="0" marL="0">
-              <a:buNone/>
-            </a:pPr>
-            <a:r>
-              <a:rPr lang="en-US" sz="1500" b="1" dirty="0">
-                <a:solidFill>
-                  <a:srgbClr val="FFFFFF"/>
-                </a:solidFill>
-              </a:rPr>
-              <a:t>3</a:t>
-            </a:r>
-            <a:endParaRPr lang="en-US" sz="1500" dirty="0"/>
-          </a:p>
-        </p:txBody>
-      </p:sp>
-      <p:sp>
-        <p:nvSpPr>
-          <p:cNvPr id="12" name="Text 10"/>
-          <p:cNvSpPr/>
-          <p:nvPr/>
-        </p:nvSpPr>
-        <p:spPr>
-          <a:xfrm>
-            <a:off x="1325880" y="3456432"/>
-            <a:ext cx="10241280" cy="914400"/>
-          </a:xfrm>
-          <a:prstGeom prst="rect">
-            <a:avLst/>
-          </a:prstGeom>
-          <a:noFill/>
-          <a:ln/>
-        </p:spPr>
-        <p:txBody>
-          <a:bodyPr wrap="square" lIns="0" tIns="0" rIns="0" bIns="0" rtlCol="0" anchor="ctr"/>
-          <a:lstStyle/>
-          <a:p>
-            <a:pPr indent="0" marL="0">
-              <a:lnSpc>
-                <a:spcPct val="103000"/>
-              </a:lnSpc>
-              <a:buNone/>
-            </a:pPr>
-            <a:r>
-              <a:rPr lang="en-US" sz="1400" b="1" dirty="0">
-                <a:solidFill>
-                  <a:srgbClr val="FFFFFF"/>
-                </a:solidFill>
-              </a:rPr>
-              <a:t>Site &amp; booster matter  </a:t>
-            </a:r>
-            <a:pPr indent="0" marL="0">
-              <a:lnSpc>
-                <a:spcPct val="103000"/>
-              </a:lnSpc>
-              <a:buNone/>
-            </a:pPr>
-            <a:r>
-              <a:rPr lang="en-US" sz="1250" dirty="0">
-                <a:solidFill>
-                  <a:srgbClr val="CADCFC"/>
-                </a:solidFill>
-              </a:rPr>
-              <a:t>KSC LC-39A is the most successful site and the FT-generation boosters recover most often.</a:t>
-            </a:r>
-            <a:endParaRPr lang="en-US" sz="1400" dirty="0"/>
-          </a:p>
-        </p:txBody>
-      </p:sp>
-      <p:sp>
-        <p:nvSpPr>
-          <p:cNvPr id="13" name="Shape 11"/>
-          <p:cNvSpPr/>
-          <p:nvPr/>
-        </p:nvSpPr>
-        <p:spPr>
-          <a:xfrm>
-            <a:off x="731520" y="4489704"/>
-            <a:ext cx="384048" cy="384048"/>
-          </a:xfrm>
-          <a:prstGeom prst="ellipse">
-            <a:avLst/>
-          </a:prstGeom>
-          <a:solidFill>
-            <a:srgbClr val="FC3D21"/>
-          </a:solidFill>
-          <a:ln/>
-        </p:spPr>
-      </p:sp>
-      <p:sp>
-        <p:nvSpPr>
-          <p:cNvPr id="14" name="Text 12"/>
-          <p:cNvSpPr/>
-          <p:nvPr/>
-        </p:nvSpPr>
-        <p:spPr>
-          <a:xfrm>
-            <a:off x="731520" y="4489704"/>
-            <a:ext cx="384048" cy="384048"/>
-          </a:xfrm>
-          <a:prstGeom prst="rect">
-            <a:avLst/>
-          </a:prstGeom>
-          <a:noFill/>
-          <a:ln/>
-        </p:spPr>
-        <p:txBody>
-          <a:bodyPr wrap="square" lIns="0" tIns="0" rIns="0" bIns="0" rtlCol="0" anchor="ctr"/>
-          <a:lstStyle/>
-          <a:p>
-            <a:pPr algn="ctr" indent="0" marL="0">
-              <a:buNone/>
-            </a:pPr>
-            <a:r>
-              <a:rPr lang="en-US" sz="1500" b="1" dirty="0">
-                <a:solidFill>
-                  <a:srgbClr val="FFFFFF"/>
-                </a:solidFill>
-              </a:rPr>
-              <a:t>4</a:t>
-            </a:r>
-            <a:endParaRPr lang="en-US" sz="1500" dirty="0"/>
-          </a:p>
-        </p:txBody>
-      </p:sp>
-      <p:sp>
-        <p:nvSpPr>
-          <p:cNvPr id="15" name="Text 13"/>
-          <p:cNvSpPr/>
-          <p:nvPr/>
-        </p:nvSpPr>
-        <p:spPr>
-          <a:xfrm>
-            <a:off x="1325880" y="4407408"/>
-            <a:ext cx="10241280" cy="914400"/>
-          </a:xfrm>
-          <a:prstGeom prst="rect">
-            <a:avLst/>
-          </a:prstGeom>
-          <a:noFill/>
-          <a:ln/>
-        </p:spPr>
-        <p:txBody>
-          <a:bodyPr wrap="square" lIns="0" tIns="0" rIns="0" bIns="0" rtlCol="0" anchor="ctr"/>
-          <a:lstStyle/>
-          <a:p>
-            <a:pPr indent="0" marL="0">
-              <a:lnSpc>
-                <a:spcPct val="103000"/>
-              </a:lnSpc>
-              <a:buNone/>
-            </a:pPr>
-            <a:r>
-              <a:rPr lang="en-US" sz="1400" b="1" dirty="0">
-                <a:solidFill>
-                  <a:srgbClr val="FFFFFF"/>
-                </a:solidFill>
-              </a:rPr>
-              <a:t>Prediction works — with a caveat  </a:t>
-            </a:r>
-            <a:pPr indent="0" marL="0">
-              <a:lnSpc>
-                <a:spcPct val="103000"/>
-              </a:lnSpc>
-              <a:buNone/>
-            </a:pPr>
-            <a:r>
-              <a:rPr lang="en-US" sz="1250" dirty="0">
-                <a:solidFill>
-                  <a:srgbClr val="CADCFC"/>
-                </a:solidFill>
-              </a:rPr>
-              <a:t>Four classifiers reach ~83% test accuracy (SVM best on CV). With only 18 test samples the models are effectively tied; more data is needed to separate them.</a:t>
-            </a:r>
-            <a:endParaRPr lang="en-US" sz="1400" dirty="0"/>
-          </a:p>
-        </p:txBody>
-      </p:sp>
-      <p:sp>
-        <p:nvSpPr>
-          <p:cNvPr id="16" name="Shape 14"/>
-          <p:cNvSpPr/>
-          <p:nvPr/>
-        </p:nvSpPr>
-        <p:spPr>
-          <a:xfrm>
-            <a:off x="731520" y="5440680"/>
-            <a:ext cx="384048" cy="384048"/>
-          </a:xfrm>
-          <a:prstGeom prst="ellipse">
-            <a:avLst/>
-          </a:prstGeom>
-          <a:solidFill>
-            <a:srgbClr val="FC3D21"/>
-          </a:solidFill>
-          <a:ln/>
-        </p:spPr>
-      </p:sp>
-      <p:sp>
-        <p:nvSpPr>
-          <p:cNvPr id="17" name="Text 15"/>
-          <p:cNvSpPr/>
-          <p:nvPr/>
-        </p:nvSpPr>
-        <p:spPr>
-          <a:xfrm>
-            <a:off x="731520" y="5440680"/>
-            <a:ext cx="384048" cy="384048"/>
-          </a:xfrm>
-          <a:prstGeom prst="rect">
-            <a:avLst/>
-          </a:prstGeom>
-          <a:noFill/>
-          <a:ln/>
-        </p:spPr>
-        <p:txBody>
-          <a:bodyPr wrap="square" lIns="0" tIns="0" rIns="0" bIns="0" rtlCol="0" anchor="ctr"/>
-          <a:lstStyle/>
-          <a:p>
-            <a:pPr algn="ctr" indent="0" marL="0">
-              <a:buNone/>
-            </a:pPr>
-            <a:r>
-              <a:rPr lang="en-US" sz="1500" b="1" dirty="0">
-                <a:solidFill>
-                  <a:srgbClr val="FFFFFF"/>
-                </a:solidFill>
-              </a:rPr>
-              <a:t>5</a:t>
-            </a:r>
-            <a:endParaRPr lang="en-US" sz="1500" dirty="0"/>
-          </a:p>
-        </p:txBody>
-      </p:sp>
-      <p:sp>
-        <p:nvSpPr>
-          <p:cNvPr id="18" name="Text 16"/>
-          <p:cNvSpPr/>
-          <p:nvPr/>
-        </p:nvSpPr>
-        <p:spPr>
-          <a:xfrm>
-            <a:off x="1325880" y="5358384"/>
-            <a:ext cx="10241280" cy="914400"/>
-          </a:xfrm>
-          <a:prstGeom prst="rect">
-            <a:avLst/>
-          </a:prstGeom>
-          <a:noFill/>
-          <a:ln/>
-        </p:spPr>
-        <p:txBody>
-          <a:bodyPr wrap="square" lIns="0" tIns="0" rIns="0" bIns="0" rtlCol="0" anchor="ctr"/>
-          <a:lstStyle/>
-          <a:p>
-            <a:pPr indent="0" marL="0">
-              <a:lnSpc>
-                <a:spcPct val="103000"/>
-              </a:lnSpc>
-              <a:buNone/>
-            </a:pPr>
-            <a:r>
-              <a:rPr lang="en-US" sz="1400" b="1" dirty="0">
-                <a:solidFill>
-                  <a:srgbClr val="FFFFFF"/>
-                </a:solidFill>
-              </a:rPr>
-              <a:t>Business takeaway  </a:t>
-            </a:r>
-            <a:pPr indent="0" marL="0">
-              <a:lnSpc>
-                <a:spcPct val="103000"/>
-              </a:lnSpc>
-              <a:buNone/>
-            </a:pPr>
-            <a:r>
-              <a:rPr lang="en-US" sz="1250" dirty="0">
-                <a:solidFill>
-                  <a:srgbClr val="CADCFC"/>
-                </a:solidFill>
-              </a:rPr>
-              <a:t>Landing — and therefore the ~$100M cost gap per launch — can be predicted from public attributes, directly informing a competitor's bid.</a:t>
-            </a:r>
-            <a:endParaRPr lang="en-US" sz="1400" dirty="0"/>
-          </a:p>
-        </p:txBody>
-      </p:sp>
-      <p:sp>
-        <p:nvSpPr>
-          <p:cNvPr id="19" name="Text 17"/>
-          <p:cNvSpPr/>
-          <p:nvPr/>
-        </p:nvSpPr>
-        <p:spPr>
-          <a:xfrm>
-            <a:off x="548640" y="6437376"/>
-            <a:ext cx="8686800" cy="274320"/>
-          </a:xfrm>
-          <a:prstGeom prst="rect">
-            <a:avLst/>
-          </a:prstGeom>
-          <a:noFill/>
-          <a:ln/>
-        </p:spPr>
-        <p:txBody>
-          <a:bodyPr wrap="square" lIns="0" tIns="0" rIns="0" bIns="0" rtlCol="0" anchor="ctr"/>
-          <a:lstStyle/>
-          <a:p>
-            <a:pPr algn="l" indent="0" marL="0">
-              <a:buNone/>
-            </a:pPr>
-            <a:r>
-              <a:rPr lang="en-US" sz="800" dirty="0">
-                <a:solidFill>
-                  <a:srgbClr val="5B6770"/>
-                </a:solidFill>
-              </a:rPr>
-              <a:t>IBM Data Science Capstone  ·  Falcon 9 First-Stage Landing Prediction</a:t>
-            </a:r>
-            <a:endParaRPr lang="en-US" sz="800" dirty="0"/>
-          </a:p>
-        </p:txBody>
-      </p:sp>
-      <p:sp>
-        <p:nvSpPr>
-          <p:cNvPr id="20" name="Text 18"/>
-          <p:cNvSpPr/>
-          <p:nvPr/>
-        </p:nvSpPr>
-        <p:spPr>
-          <a:xfrm>
-            <a:off x="11338560" y="6437376"/>
-            <a:ext cx="365760" cy="274320"/>
-          </a:xfrm>
-          <a:prstGeom prst="rect">
-            <a:avLst/>
-          </a:prstGeom>
-          <a:noFill/>
-          <a:ln/>
-        </p:spPr>
-        <p:txBody>
-          <a:bodyPr wrap="square" lIns="0" tIns="0" rIns="0" bIns="0" rtlCol="0" anchor="ctr"/>
-          <a:lstStyle/>
-          <a:p>
-            <a:pPr algn="r" indent="0" marL="0">
-              <a:buNone/>
-            </a:pPr>
-            <a:r>
-              <a:rPr lang="en-US" sz="800" dirty="0">
-                <a:solidFill>
-                  <a:srgbClr val="5B6770"/>
-                </a:solidFill>
-              </a:rPr>
-              <a:t>18</a:t>
-            </a:r>
-            <a:endParaRPr lang="en-US" sz="800" dirty="0"/>
-          </a:p>
-        </p:txBody>
-      </p:sp>
-    </p:spTree>
-  </p:cSld>
-  <p:clrMapOvr>
-    <a:masterClrMapping/>
-  </p:clrMapOvr>
-</p:sld>
-</file>
-
-<file path=ppt/slides/slide19.xml><?xml version="1.0" encoding="utf-8"?>
-<p:sld xmlns:a="http://schemas.openxmlformats.org/drawingml/2006/main" xmlns:r="http://schemas.openxmlformats.org/officeDocument/2006/relationships" xmlns:p="http://schemas.openxmlformats.org/presentationml/2006/main">
-  <p:cSld name="Slide 19">
     <p:bg>
       <p:bgPr>
         <a:solidFill>

</xml_diff>